<commit_message>
Removing chromaDB and Using Elasticsearch only for hyprid retrieval
</commit_message>
<xml_diff>
--- a/Data/pitch_decks/pitch_deck_001.pptx
+++ b/Data/pitch_decks/pitch_deck_001.pptx
@@ -3359,7 +3359,7 @@
                         <a:defRPr sz="1200"/>
                       </a:pPr>
                       <a:r>
-                        <a:t>$1,000.00</a:t>
+                        <a:t>$450.00</a:t>
                       </a:r>
                     </a:p>
                   </a:txBody>
@@ -3374,7 +3374,7 @@
                         <a:defRPr sz="1200"/>
                       </a:pPr>
                       <a:r>
-                        <a:t>AMD Ryzen processor</a:t>
+                        <a:t>Quad-core processor</a:t>
                       </a:r>
                     </a:p>
                   </a:txBody>
@@ -3389,7 +3389,7 @@
                         <a:defRPr sz="1200"/>
                       </a:pPr>
                       <a:r>
-                        <a:t>Up to 32 GB RAM</a:t>
+                        <a:t>4GB RAM (expandable)</a:t>
                       </a:r>
                     </a:p>
                   </a:txBody>
@@ -3404,7 +3404,7 @@
                         <a:defRPr sz="1200"/>
                       </a:pPr>
                       <a:r>
-                        <a:t>8-bay chassis supporting 3 x 16 TB Seagate IronWolf Pro drives</a:t>
+                        <a:t>16TB (4x4TB) RAID 6</a:t>
                       </a:r>
                     </a:p>
                   </a:txBody>
@@ -3419,7 +3419,7 @@
                         <a:defRPr sz="1200"/>
                       </a:pPr>
                       <a:r>
-                        <a:t>Manufacturer warranty applies</a:t>
+                        <a:t>Manufacturer hardware warranty</a:t>
                       </a:r>
                     </a:p>
                   </a:txBody>
@@ -3434,7 +3434,7 @@
                         <a:defRPr sz="1200"/>
                       </a:pPr>
                       <a:r>
-                        <a:t>Installation and configuration services available</a:t>
+                        <a:t>30 days installation &amp; configuration service guarantee</a:t>
                       </a:r>
                     </a:p>
                   </a:txBody>
@@ -3466,7 +3466,7 @@
                         <a:defRPr sz="1200"/>
                       </a:pPr>
                       <a:r>
-                        <a:t>$1,000.00</a:t>
+                        <a:t>$450.00</a:t>
                       </a:r>
                     </a:p>
                   </a:txBody>
@@ -3481,7 +3481,7 @@
                         <a:defRPr sz="1200"/>
                       </a:pPr>
                       <a:r>
-                        <a:t>AMD Ryzen processor</a:t>
+                        <a:t>Quad-core processor</a:t>
                       </a:r>
                     </a:p>
                   </a:txBody>
@@ -3496,7 +3496,7 @@
                         <a:defRPr sz="1200"/>
                       </a:pPr>
                       <a:r>
-                        <a:t>Up to 32 GB RAM</a:t>
+                        <a:t>4GB RAM (expandable)</a:t>
                       </a:r>
                     </a:p>
                   </a:txBody>
@@ -3511,7 +3511,7 @@
                         <a:defRPr sz="1200"/>
                       </a:pPr>
                       <a:r>
-                        <a:t>8-bay chassis supporting 3 x 16 TB Seagate IronWolf Pro drives</a:t>
+                        <a:t>16TB (4x4TB) RAID 6</a:t>
                       </a:r>
                     </a:p>
                   </a:txBody>
@@ -3526,7 +3526,7 @@
                         <a:defRPr sz="1200"/>
                       </a:pPr>
                       <a:r>
-                        <a:t>Manufacturer warranty applies</a:t>
+                        <a:t>Manufacturer hardware warranty</a:t>
                       </a:r>
                     </a:p>
                   </a:txBody>
@@ -3541,7 +3541,7 @@
                         <a:defRPr sz="1200"/>
                       </a:pPr>
                       <a:r>
-                        <a:t>Installation and configuration services available</a:t>
+                        <a:t>30 days installation &amp; configuration service guarantee</a:t>
                       </a:r>
                     </a:p>
                   </a:txBody>
@@ -3573,7 +3573,7 @@
                         <a:defRPr sz="1200"/>
                       </a:pPr>
                       <a:r>
-                        <a:t>$1,000.00</a:t>
+                        <a:t>$450.00</a:t>
                       </a:r>
                     </a:p>
                   </a:txBody>
@@ -3588,7 +3588,7 @@
                         <a:defRPr sz="1200"/>
                       </a:pPr>
                       <a:r>
-                        <a:t>AMD Ryzen processor</a:t>
+                        <a:t>Quad-core processor</a:t>
                       </a:r>
                     </a:p>
                   </a:txBody>
@@ -3603,7 +3603,7 @@
                         <a:defRPr sz="1200"/>
                       </a:pPr>
                       <a:r>
-                        <a:t>Up to 32 GB RAM</a:t>
+                        <a:t>4GB RAM (expandable)</a:t>
                       </a:r>
                     </a:p>
                   </a:txBody>
@@ -3618,7 +3618,7 @@
                         <a:defRPr sz="1200"/>
                       </a:pPr>
                       <a:r>
-                        <a:t>8-bay chassis supporting 3 x 16 TB Seagate IronWolf Pro drives</a:t>
+                        <a:t>16TB (4x4TB) RAID 6</a:t>
                       </a:r>
                     </a:p>
                   </a:txBody>
@@ -3633,7 +3633,7 @@
                         <a:defRPr sz="1200"/>
                       </a:pPr>
                       <a:r>
-                        <a:t>Manufacturer warranty applies</a:t>
+                        <a:t>Manufacturer hardware warranty</a:t>
                       </a:r>
                     </a:p>
                   </a:txBody>
@@ -3648,7 +3648,7 @@
                         <a:defRPr sz="1200"/>
                       </a:pPr>
                       <a:r>
-                        <a:t>Installation and configuration services available</a:t>
+                        <a:t>30 days installation &amp; configuration service guarantee</a:t>
                       </a:r>
                     </a:p>
                   </a:txBody>
@@ -3790,7 +3790,7 @@
               </a:defRPr>
             </a:pPr>
             <a:r>
-              <a:t>• Otsuka Corporation requires a robust NAS server solution for backing up 16 TB of video data.</a:t>
+              <a:t>• Otsuka Corporation requires a reliable NAS server solution to support video backup operations.</a:t>
             </a:r>
           </a:p>
           <a:p>
@@ -3806,7 +3806,7 @@
               </a:defRPr>
             </a:pPr>
             <a:r>
-              <a:t>• High transfer speeds are essential to handle large video files efficiently.</a:t>
+              <a:t>• Supports an IT environment with 200 employees requiring efficient data storage and protection.</a:t>
             </a:r>
           </a:p>
           <a:p>
@@ -3822,7 +3822,7 @@
               </a:defRPr>
             </a:pPr>
             <a:r>
-              <a:t>• Reliable data redundancy is critical to ensure data integrity and availability.</a:t>
+              <a:t>• Needs a storage capacity of 16TB configured in RAID 6 for data redundancy and security.</a:t>
             </a:r>
           </a:p>
           <a:p>
@@ -3838,7 +3838,7 @@
               </a:defRPr>
             </a:pPr>
             <a:r>
-              <a:t>• The solution must support scalability for future storage growth.</a:t>
+              <a:t>• Requires a transfer speed of 2.5 Gbps to ensure efficient handling of large video files.</a:t>
             </a:r>
           </a:p>
           <a:p>
@@ -3854,7 +3854,7 @@
               </a:defRPr>
             </a:pPr>
             <a:r>
-              <a:t>• Efficient video backup management is needed in their IT services environment.</a:t>
+              <a:t>• Solution must be scalable, secure, and optimized for video backup infrastructure.</a:t>
             </a:r>
           </a:p>
         </p:txBody>
@@ -3990,7 +3990,7 @@
               </a:defRPr>
             </a:pPr>
             <a:r>
-              <a:t>• A comprehensive NAS Video Backup Solution tailored for Otsuka Corporation's needs.</a:t>
+              <a:t>• A tailored NAS server solution designed specifically for video backup needs.</a:t>
             </a:r>
           </a:p>
           <a:p>
@@ -4006,7 +4006,7 @@
               </a:defRPr>
             </a:pPr>
             <a:r>
-              <a:t>• Includes an 8-bay Synology DiskStation DS1821+ with AMD Ryzen processor for powerful performance.</a:t>
+              <a:t>• Includes high-performance NAS device with built-in 2.5 Gigabit Ethernet ports.</a:t>
             </a:r>
           </a:p>
           <a:p>
@@ -4022,7 +4022,7 @@
               </a:defRPr>
             </a:pPr>
             <a:r>
-              <a:t>• Three Seagate IronWolf Pro 16 TB NAS drives configured for RAID 5 for data redundancy and speed.</a:t>
+              <a:t>• Configured RAID 6 setup for enhanced data protection and fault tolerance.</a:t>
             </a:r>
           </a:p>
           <a:p>
@@ -4038,7 +4038,7 @@
               </a:defRPr>
             </a:pPr>
             <a:r>
-              <a:t>• High-speed 10 GbE networking enabled by Intel X550-T2 NIC and Netgear ProSAFE XS708E switch.</a:t>
+              <a:t>• Comprehensive setup and configuration service to optimize network and backup environment.</a:t>
             </a:r>
           </a:p>
           <a:p>
@@ -4054,7 +4054,7 @@
               </a:defRPr>
             </a:pPr>
             <a:r>
-              <a:t>• Cat6a Ethernet cables ensure optimal network performance and reliable data transfer.</a:t>
+              <a:t>• Reliable UPS system included to maintain data integrity during power disruptions.</a:t>
             </a:r>
           </a:p>
         </p:txBody>
@@ -4190,7 +4190,7 @@
               </a:defRPr>
             </a:pPr>
             <a:r>
-              <a:t>• Synology DiskStation DS1821+: 8-bay NAS chassis with AMD Ryzen processor.</a:t>
+              <a:t>• NAS Device: Asustor AS5304T with quad-core processor and 4GB RAM (expandable).</a:t>
             </a:r>
           </a:p>
           <a:p>
@@ -4206,7 +4206,7 @@
               </a:defRPr>
             </a:pPr>
             <a:r>
-              <a:t>• Supports up to 32 GB RAM for enhanced multitasking and performance.</a:t>
+              <a:t>• Storage: Four Seagate IronWolf 4TB NAS hard drives totaling 16TB, RAID 6 configured.</a:t>
             </a:r>
           </a:p>
           <a:p>
@@ -4222,7 +4222,7 @@
               </a:defRPr>
             </a:pPr>
             <a:r>
-              <a:t>• RAID configurations and SSD caching available for data redundancy and speed.</a:t>
+              <a:t>• Network: Built-in 2.5 Gigabit Ethernet ports for high-speed data transfer.</a:t>
             </a:r>
           </a:p>
           <a:p>
@@ -4238,7 +4238,7 @@
               </a:defRPr>
             </a:pPr>
             <a:r>
-              <a:t>• Seagate IronWolf Pro 16 TB NAS Drives: NAS-optimized with AgileArray technology.</a:t>
+              <a:t>• Backup Protection: APC Back-UPS Pro 1500VA for power backup and surge protection.</a:t>
             </a:r>
           </a:p>
           <a:p>
@@ -4254,7 +4254,7 @@
               </a:defRPr>
             </a:pPr>
             <a:r>
-              <a:t>• Intel X550-T2 Dual Port 10 GbE NIC and Netgear XS708E 8-Port 10 GbE Switch for fast networking.</a:t>
+              <a:t>• Service: Professional NAS setup, RAID configuration, and network optimization.</a:t>
             </a:r>
           </a:p>
         </p:txBody>
@@ -4390,7 +4390,7 @@
               </a:defRPr>
             </a:pPr>
             <a:r>
-              <a:t>• Synology DiskStation DS1821+: $1,000.00</a:t>
+              <a:t>• Asustor AS5304T NAS Device: $450.00</a:t>
             </a:r>
           </a:p>
           <a:p>
@@ -4406,7 +4406,7 @@
               </a:defRPr>
             </a:pPr>
             <a:r>
-              <a:t>• Three Seagate IronWolf Pro 16 TB Drives: $1,320.00</a:t>
+              <a:t>• Seagate IronWolf 4TB NAS Hard Drives (4 units): $440.00</a:t>
             </a:r>
           </a:p>
           <a:p>
@@ -4422,7 +4422,7 @@
               </a:defRPr>
             </a:pPr>
             <a:r>
-              <a:t>• Intel X550-T2 Dual Port 10 GbE NIC: $250.00</a:t>
+              <a:t>• APC Back-UPS Pro 1500VA UPS: $220.00</a:t>
             </a:r>
           </a:p>
           <a:p>
@@ -4438,7 +4438,7 @@
               </a:defRPr>
             </a:pPr>
             <a:r>
-              <a:t>• Netgear ProSAFE XS708E 8-Port 10 GbE Switch: $700.00</a:t>
+              <a:t>• NAS Setup and Configuration Service: $300.00</a:t>
             </a:r>
           </a:p>
           <a:p>
@@ -4454,23 +4454,7 @@
               </a:defRPr>
             </a:pPr>
             <a:r>
-              <a:t>• Cat6a Ethernet Cables (4 packs): $100.00</a:t>
-            </a:r>
-          </a:p>
-          <a:p>
-            <a:pPr>
-              <a:spcAft>
-                <a:spcPts val="1200"/>
-              </a:spcAft>
-              <a:defRPr sz="2000">
-                <a:solidFill>
-                  <a:srgbClr val="505050"/>
-                </a:solidFill>
-                <a:latin typeface="Segoe UI"/>
-              </a:defRPr>
-            </a:pPr>
-            <a:r>
-              <a:t>• Subtotal: $3,370.00 | Tax (8%): $269.60 | Total: $3,639.60 USD</a:t>
+              <a:t>• Subtotal: $1,410.00 | Tax (8%): $112.80 | Total: $1,522.80 USD</a:t>
             </a:r>
           </a:p>
         </p:txBody>
@@ -4606,7 +4590,7 @@
               </a:defRPr>
             </a:pPr>
             <a:r>
-              <a:t>• Hardware warranty is provided according to manufacturer terms.</a:t>
+              <a:t>• Hardware warranty provided by respective manufacturers for all devices.</a:t>
             </a:r>
           </a:p>
           <a:p>
@@ -4622,7 +4606,7 @@
               </a:defRPr>
             </a:pPr>
             <a:r>
-              <a:t>• Installation and configuration services available at additional cost.</a:t>
+              <a:t>• Installation and configuration services guaranteed for 30 days post-completion.</a:t>
             </a:r>
           </a:p>
           <a:p>
@@ -4638,7 +4622,7 @@
               </a:defRPr>
             </a:pPr>
             <a:r>
-              <a:t>• Otsuka Corporation responsible for network compatibility and infrastructure readiness.</a:t>
+              <a:t>• Technical support available for setup and network optimization.</a:t>
             </a:r>
           </a:p>
           <a:p>
@@ -4654,7 +4638,7 @@
               </a:defRPr>
             </a:pPr>
             <a:r>
-              <a:t>• Support includes setup of RAID 5 for data redundancy and performance optimization.</a:t>
+              <a:t>• Power backup ensures data integrity during outages and fluctuations.</a:t>
             </a:r>
           </a:p>
           <a:p>
@@ -4670,7 +4654,7 @@
               </a:defRPr>
             </a:pPr>
             <a:r>
-              <a:t>• Training sessions for IT staff on NAS management and backup procedures can be arranged.</a:t>
+              <a:t>• Additional hardware or software needs can be quoted separately.</a:t>
             </a:r>
           </a:p>
         </p:txBody>
@@ -4806,7 +4790,7 @@
               </a:defRPr>
             </a:pPr>
             <a:r>
-              <a:t>• Three variants of the Synology DiskStation DS1821+ tailored for different needs.</a:t>
+              <a:t>• Compare three variants of our NAS solution tailored for video backup.</a:t>
             </a:r>
           </a:p>
           <a:p>
@@ -4822,7 +4806,7 @@
               </a:defRPr>
             </a:pPr>
             <a:r>
-              <a:t>• All variants include AMD Ryzen processor and support up to 32 GB RAM.</a:t>
+              <a:t>• All variants offer identical high performance and reliability.</a:t>
             </a:r>
           </a:p>
           <a:p>
@@ -4838,7 +4822,7 @@
               </a:defRPr>
             </a:pPr>
             <a:r>
-              <a:t>• Each variant supports RAID configurations and SSD caching for video backup reliability.</a:t>
+              <a:t>• Choose based on preferred product naming or internal cataloging.</a:t>
             </a:r>
           </a:p>
           <a:p>
@@ -4854,7 +4838,7 @@
               </a:defRPr>
             </a:pPr>
             <a:r>
-              <a:t>• Pricing varies slightly to reflect potential customization options.</a:t>
+              <a:t>• Consistent pricing and specifications ensure uniform quality.</a:t>
             </a:r>
           </a:p>
           <a:p>
@@ -4870,7 +4854,7 @@
               </a:defRPr>
             </a:pPr>
             <a:r>
-              <a:t>• All options ensure high-speed 10 GbE connectivity and scalable storage.</a:t>
+              <a:t>• Helps in decision making with clear and transparent comparison.</a:t>
             </a:r>
           </a:p>
         </p:txBody>
@@ -5006,7 +4990,7 @@
               </a:defRPr>
             </a:pPr>
             <a:r>
-              <a:t>• Quote valid until July 31, 2024.</a:t>
+              <a:t>• Coordinate delivery of NAS device and hard drives to Otsuka Corporation IT department.</a:t>
             </a:r>
           </a:p>
           <a:p>
@@ -5022,7 +5006,7 @@
               </a:defRPr>
             </a:pPr>
             <a:r>
-              <a:t>• Installation and configuration to be scheduled upon quote approval.</a:t>
+              <a:t>• Schedule installation and configuration service within 2 weeks of order confirmation.</a:t>
             </a:r>
           </a:p>
           <a:p>
@@ -5038,7 +5022,7 @@
               </a:defRPr>
             </a:pPr>
             <a:r>
-              <a:t>• Delivery timeline depends on procurement and network infrastructure readiness.</a:t>
+              <a:t>• Ensure network infrastructure supports 2.5 Gbps transfer speeds before setup.</a:t>
             </a:r>
           </a:p>
           <a:p>
@@ -5054,7 +5038,7 @@
               </a:defRPr>
             </a:pPr>
             <a:r>
-              <a:t>• Upgrades to NAS RAM to be assessed and implemented as needed.</a:t>
+              <a:t>• Perform RAID 6 configuration and verify data redundancy and backup functionality.</a:t>
             </a:r>
           </a:p>
           <a:p>
@@ -5070,7 +5054,7 @@
               </a:defRPr>
             </a:pPr>
             <a:r>
-              <a:t>• Backup and restore testing to ensure data integrity post-installation.</a:t>
+              <a:t>• Timely delivery ensures minimal disruption to video backup operations.</a:t>
             </a:r>
           </a:p>
         </p:txBody>
@@ -5206,7 +5190,7 @@
               </a:defRPr>
             </a:pPr>
             <a:r>
-              <a:t>• Review and approve the quotation to initiate procurement.</a:t>
+              <a:t>• Review and approve the quotation to proceed with the order.</a:t>
             </a:r>
           </a:p>
           <a:p>
@@ -5222,7 +5206,7 @@
               </a:defRPr>
             </a:pPr>
             <a:r>
-              <a:t>• Confirm budget and timeline to align with project goals.</a:t>
+              <a:t>• Confirm delivery address and provide accurate contact details.</a:t>
             </a:r>
           </a:p>
           <a:p>
@@ -5238,7 +5222,7 @@
               </a:defRPr>
             </a:pPr>
             <a:r>
-              <a:t>• Schedule installation and configuration with our technical team.</a:t>
+              <a:t>• Schedule installation date with our technical team at your convenience.</a:t>
             </a:r>
           </a:p>
           <a:p>
@@ -5254,7 +5238,7 @@
               </a:defRPr>
             </a:pPr>
             <a:r>
-              <a:t>• Provide network infrastructure details for compatibility assessment.</a:t>
+              <a:t>• Communicate any additional requirements or questions to our sales representative.</a:t>
             </a:r>
           </a:p>
           <a:p>
@@ -5270,7 +5254,7 @@
               </a:defRPr>
             </a:pPr>
             <a:r>
-              <a:t>• Plan training sessions to empower your IT staff on the new system.</a:t>
+              <a:t>• Secure your reliable NAS server solution tailored for your video backup needs.</a:t>
             </a:r>
           </a:p>
         </p:txBody>

</xml_diff>

<commit_message>
changed quote message to multilingual
</commit_message>
<xml_diff>
--- a/Data/pitch_decks/pitch_deck_001.pptx
+++ b/Data/pitch_decks/pitch_deck_001.pptx
@@ -3374,7 +3374,7 @@
                         <a:defRPr sz="1200"/>
                       </a:pPr>
                       <a:r>
-                        <a:t>Intel Core i7 第11世代</a:t>
+                        <a:t>Intel Core i7</a:t>
                       </a:r>
                     </a:p>
                   </a:txBody>
@@ -3419,7 +3419,7 @@
                         <a:defRPr sz="1200"/>
                       </a:pPr>
                       <a:r>
-                        <a:t>3年オンサイト対応</a:t>
+                        <a:t>3年間オンサイト保証</a:t>
                       </a:r>
                     </a:p>
                   </a:txBody>
@@ -3434,7 +3434,7 @@
                         <a:defRPr sz="1200"/>
                       </a:pPr>
                       <a:r>
-                        <a:t>翌営業日オンサイトサポート</a:t>
+                        <a:t>日本語電話・チャットサポート</a:t>
                       </a:r>
                     </a:p>
                   </a:txBody>
@@ -3481,7 +3481,7 @@
                         <a:defRPr sz="1200"/>
                       </a:pPr>
                       <a:r>
-                        <a:t>Intel Core i7 第11世代</a:t>
+                        <a:t>Intel Core i7</a:t>
                       </a:r>
                     </a:p>
                   </a:txBody>
@@ -3526,7 +3526,7 @@
                         <a:defRPr sz="1200"/>
                       </a:pPr>
                       <a:r>
-                        <a:t>3年オンサイト対応</a:t>
+                        <a:t>3年間オンサイト保証</a:t>
                       </a:r>
                     </a:p>
                   </a:txBody>
@@ -3541,7 +3541,7 @@
                         <a:defRPr sz="1200"/>
                       </a:pPr>
                       <a:r>
-                        <a:t>翌営業日オンサイトサポート</a:t>
+                        <a:t>日本語電話・チャットサポート</a:t>
                       </a:r>
                     </a:p>
                   </a:txBody>
@@ -3588,7 +3588,7 @@
                         <a:defRPr sz="1200"/>
                       </a:pPr>
                       <a:r>
-                        <a:t>Intel Core i7 第11世代</a:t>
+                        <a:t>Intel Core i7</a:t>
                       </a:r>
                     </a:p>
                   </a:txBody>
@@ -3633,7 +3633,7 @@
                         <a:defRPr sz="1200"/>
                       </a:pPr>
                       <a:r>
-                        <a:t>3年オンサイト対応</a:t>
+                        <a:t>3年間オンサイト保証</a:t>
                       </a:r>
                     </a:p>
                   </a:txBody>
@@ -3648,7 +3648,7 @@
                         <a:defRPr sz="1200"/>
                       </a:pPr>
                       <a:r>
-                        <a:t>翌営業日オンサイトサポート</a:t>
+                        <a:t>日本語電話・チャットサポート</a:t>
                       </a:r>
                     </a:p>
                   </a:txBody>
@@ -3790,7 +3790,7 @@
               </a:defRPr>
             </a:pPr>
             <a:r>
-              <a:t>• 株式会社クロステック様はコンサルティング業務での効率化を求めています。</a:t>
+              <a:t>• 株式会社クロステック様はコンサルティング業務での効率化を目指しています。</a:t>
             </a:r>
           </a:p>
           <a:p>
@@ -3806,7 +3806,7 @@
               </a:defRPr>
             </a:pPr>
             <a:r>
-              <a:t>• 主な用途は資料作成、Zoom会議、軽いグラフィック編集です。</a:t>
+              <a:t>• 資料作成、Zoom会議、プレゼンテーション、軽いグラフィック編集が主な作業。</a:t>
             </a:r>
           </a:p>
           <a:p>
@@ -3822,7 +3822,7 @@
               </a:defRPr>
             </a:pPr>
             <a:r>
-              <a:t>• 軽量かつ長時間バッテリー駆動のノートPCが必要です。</a:t>
+              <a:t>• 軽量かつ高解像度ディスプレイ搭載のノートパソコンを5台導入希望。</a:t>
             </a:r>
           </a:p>
           <a:p>
@@ -3838,7 +3838,7 @@
               </a:defRPr>
             </a:pPr>
             <a:r>
-              <a:t>• 高解像度ディスプレイで画面の見やすさも重視。</a:t>
+              <a:t>• 長時間バッテリー駆動と静音設計を重視。</a:t>
             </a:r>
           </a:p>
           <a:p>
@@ -3854,23 +3854,7 @@
               </a:defRPr>
             </a:pPr>
             <a:r>
-              <a:t>• 業務の安定性と迅速なトラブル対応が不可欠です。</a:t>
-            </a:r>
-          </a:p>
-          <a:p>
-            <a:pPr>
-              <a:spcAft>
-                <a:spcPts val="1200"/>
-              </a:spcAft>
-              <a:defRPr sz="2000">
-                <a:solidFill>
-                  <a:srgbClr val="505050"/>
-                </a:solidFill>
-                <a:latin typeface="Segoe UI"/>
-              </a:defRPr>
-            </a:pPr>
-            <a:r>
-              <a:t>• 3年間のハードウェア保証と翌営業日オンサイト対応が必須条件です。</a:t>
+              <a:t>• 迅速な故障対応と3年間のハードウェア保証、全国対応のオンサイトサポートを求めています。</a:t>
             </a:r>
           </a:p>
         </p:txBody>
@@ -4006,7 +3990,7 @@
               </a:defRPr>
             </a:pPr>
             <a:r>
-              <a:t>• 高性能かつ軽量な15.6インチノートPCを5台ご提案。</a:t>
+              <a:t>• 高性能15.6インチノートPCモデルCを5台ご提案。</a:t>
             </a:r>
           </a:p>
           <a:p>
@@ -4022,7 +4006,7 @@
               </a:defRPr>
             </a:pPr>
             <a:r>
-              <a:t>• Intel Core i7 第11世代搭載で快適な処理速度を実現。</a:t>
+              <a:t>• 法人向け3年オンサイト対応保証と日本語電話サポート付き。</a:t>
             </a:r>
           </a:p>
           <a:p>
@@ -4038,7 +4022,7 @@
               </a:defRPr>
             </a:pPr>
             <a:r>
-              <a:t>• 最大15時間駆動の長時間バッテリーで外出先でも安心。</a:t>
+              <a:t>• 延長保証プランで翌営業日オンサイト対応を実現。</a:t>
             </a:r>
           </a:p>
           <a:p>
@@ -4054,7 +4038,7 @@
               </a:defRPr>
             </a:pPr>
             <a:r>
-              <a:t>• 3年間のハードウェア保証と全国対応の翌営業日オンサイトサポート付き。</a:t>
+              <a:t>• 日本語電話・チャットサポートプランで迅速な問題解決を支援。</a:t>
             </a:r>
           </a:p>
           <a:p>
@@ -4070,23 +4054,7 @@
               </a:defRPr>
             </a:pPr>
             <a:r>
-              <a:t>• 法人向け延長保証プランでさらなる安心を提供。</a:t>
-            </a:r>
-          </a:p>
-          <a:p>
-            <a:pPr>
-              <a:spcAft>
-                <a:spcPts val="1200"/>
-              </a:spcAft>
-              <a:defRPr sz="2000">
-                <a:solidFill>
-                  <a:srgbClr val="505050"/>
-                </a:solidFill>
-                <a:latin typeface="Segoe UI"/>
-              </a:defRPr>
-            </a:pPr>
-            <a:r>
-              <a:t>• 必要に応じてグラフィック性能強化モデルもご用意可能です。</a:t>
+              <a:t>• 軽量・長時間駆動・静音設計で業務効率を最大化。</a:t>
             </a:r>
           </a:p>
         </p:txBody>
@@ -4140,7 +4108,7 @@
               </a:defRPr>
             </a:pPr>
             <a:r>
-              <a:t>Product Overview</a:t>
+              <a:t>Product Overview (Specifications)</a:t>
             </a:r>
           </a:p>
         </p:txBody>
@@ -4222,7 +4190,7 @@
               </a:defRPr>
             </a:pPr>
             <a:r>
-              <a:t>• モデルC：高性能＆長時間バッテリー15.6インチノートPC</a:t>
+              <a:t>• CPU: Intel Core i7搭載で高い処理性能を実現。</a:t>
             </a:r>
           </a:p>
           <a:p>
@@ -4238,7 +4206,7 @@
               </a:defRPr>
             </a:pPr>
             <a:r>
-              <a:t>• CPU: Intel Core i7 第11世代</a:t>
+              <a:t>• メモリ: 16GB RAMでマルチタスクもスムーズ。</a:t>
             </a:r>
           </a:p>
           <a:p>
@@ -4254,7 +4222,7 @@
               </a:defRPr>
             </a:pPr>
             <a:r>
-              <a:t>• メモリ: 16GB</a:t>
+              <a:t>• ストレージ: 512GB SSDで高速アクセスと大容量を両立。</a:t>
             </a:r>
           </a:p>
           <a:p>
@@ -4270,7 +4238,7 @@
               </a:defRPr>
             </a:pPr>
             <a:r>
-              <a:t>• ストレージ: 512GB SSD</a:t>
+              <a:t>• ディスプレイ: 15.6インチフルHD高解像度で見やすい画面。</a:t>
             </a:r>
           </a:p>
           <a:p>
@@ -4286,7 +4254,7 @@
               </a:defRPr>
             </a:pPr>
             <a:r>
-              <a:t>• ディスプレイ: 15.6インチ フルHD</a:t>
+              <a:t>• 重量: 約1.6kgの軽量設計で持ち運びも快適。</a:t>
             </a:r>
           </a:p>
           <a:p>
@@ -4302,7 +4270,7 @@
               </a:defRPr>
             </a:pPr>
             <a:r>
-              <a:t>• 重量: 約1.6kg、最大15時間駆動、静音設計</a:t>
+              <a:t>• バッテリー: 最大15時間駆動、静音設計で快適な作業環境を提供。</a:t>
             </a:r>
           </a:p>
         </p:txBody>
@@ -4438,7 +4406,7 @@
               </a:defRPr>
             </a:pPr>
             <a:r>
-              <a:t>• ノートPC 5台：900,000円 (1台あたり180,000円)</a:t>
+              <a:t>• モデルCノートPC（5台）合計: ¥900,000</a:t>
             </a:r>
           </a:p>
           <a:p>
@@ -4454,7 +4422,7 @@
               </a:defRPr>
             </a:pPr>
             <a:r>
-              <a:t>• 法人向け3年延長保証・翌営業日オンサイトサポートプラン 5台分：75,000円</a:t>
+              <a:t>• 延長保証プラン（5台分）: ¥40,000</a:t>
             </a:r>
           </a:p>
           <a:p>
@@ -4470,7 +4438,7 @@
               </a:defRPr>
             </a:pPr>
             <a:r>
-              <a:t>• 小計：975,000円</a:t>
+              <a:t>• 法人向け電話・チャットサポートプラン（3年間）: ¥35,000</a:t>
             </a:r>
           </a:p>
           <a:p>
@@ -4486,7 +4454,7 @@
               </a:defRPr>
             </a:pPr>
             <a:r>
-              <a:t>• 消費税（10%）：97,500円</a:t>
+              <a:t>• 小計: ¥975,000</a:t>
             </a:r>
           </a:p>
           <a:p>
@@ -4502,7 +4470,7 @@
               </a:defRPr>
             </a:pPr>
             <a:r>
-              <a:t>• 合計金額：1,072,500円</a:t>
+              <a:t>• 消費税10%: ¥97,500</a:t>
             </a:r>
           </a:p>
           <a:p>
@@ -4518,7 +4486,7 @@
               </a:defRPr>
             </a:pPr>
             <a:r>
-              <a:t>• コストパフォーマンスに優れた安心のトータルサポートプラン</a:t>
+              <a:t>• 合計金額: ¥1,072,500</a:t>
             </a:r>
           </a:p>
         </p:txBody>
@@ -4654,7 +4622,7 @@
               </a:defRPr>
             </a:pPr>
             <a:r>
-              <a:t>• 3年間のハードウェア保証を標準装備。</a:t>
+              <a:t>• 3年間の法人向けオンサイト保証付き。</a:t>
             </a:r>
           </a:p>
           <a:p>
@@ -4670,7 +4638,7 @@
               </a:defRPr>
             </a:pPr>
             <a:r>
-              <a:t>• 全国対応の翌営業日オンサイトサポートで迅速なトラブル対応。</a:t>
+              <a:t>• 故障時は翌営業日に全国対応でオンサイトサポート。</a:t>
             </a:r>
           </a:p>
           <a:p>
@@ -4686,7 +4654,7 @@
               </a:defRPr>
             </a:pPr>
             <a:r>
-              <a:t>• 法人向け延長保証プランでさらに安心のサポート。</a:t>
+              <a:t>• 日本語対応の電話・チャットサポートで迅速なトラブル解決。</a:t>
             </a:r>
           </a:p>
           <a:p>
@@ -4702,7 +4670,7 @@
               </a:defRPr>
             </a:pPr>
             <a:r>
-              <a:t>• 日本語電話サポート付きでいつでも相談可能。</a:t>
+              <a:t>• 延長保証プランで安心の長期サポートを提供。</a:t>
             </a:r>
           </a:p>
           <a:p>
@@ -4718,23 +4686,7 @@
               </a:defRPr>
             </a:pPr>
             <a:r>
-              <a:t>• 大阪支社を含む全国全拠点をカバー。</a:t>
-            </a:r>
-          </a:p>
-          <a:p>
-            <a:pPr>
-              <a:spcAft>
-                <a:spcPts val="1200"/>
-              </a:spcAft>
-              <a:defRPr sz="2000">
-                <a:solidFill>
-                  <a:srgbClr val="505050"/>
-                </a:solidFill>
-                <a:latin typeface="Segoe UI"/>
-              </a:defRPr>
-            </a:pPr>
-            <a:r>
-              <a:t>• 安定した業務運用を強力にバックアップします。</a:t>
+              <a:t>• 大阪支社も含む全国対応体制で安心のサービスネットワーク。</a:t>
             </a:r>
           </a:p>
         </p:txBody>
@@ -4870,7 +4822,7 @@
               </a:defRPr>
             </a:pPr>
             <a:r>
-              <a:t>• 以下の3モデルでニーズに合わせた選択が可能です。</a:t>
+              <a:t>• 3つのバリエーションで性能は同等、名称のみ異なります。</a:t>
             </a:r>
           </a:p>
           <a:p>
@@ -4886,7 +4838,7 @@
               </a:defRPr>
             </a:pPr>
             <a:r>
-              <a:t>• 全てIntel Core i7 第11世代、16GBメモリ、512GB SSD搭載。</a:t>
+              <a:t>• すべて15.6インチフルHDディスプレイ搭載。</a:t>
             </a:r>
           </a:p>
           <a:p>
@@ -4902,7 +4854,7 @@
               </a:defRPr>
             </a:pPr>
             <a:r>
-              <a:t>• ディスプレイは15.6インチ フルHDで快適な視認性。</a:t>
+              <a:t>• Intel Core i7、16GB RAM、512GB SSDの高性能構成。</a:t>
             </a:r>
           </a:p>
           <a:p>
@@ -4918,7 +4870,7 @@
               </a:defRPr>
             </a:pPr>
             <a:r>
-              <a:t>• 重量は約1.6～1.7kg、バッテリー駆動時間は14～15時間。</a:t>
+              <a:t>• 3年間のオンサイト保証と日本語サポート付き。</a:t>
             </a:r>
           </a:p>
           <a:p>
@@ -4934,23 +4886,7 @@
               </a:defRPr>
             </a:pPr>
             <a:r>
-              <a:t>• 3年間のオンサイト対応保証付きで安心。</a:t>
-            </a:r>
-          </a:p>
-          <a:p>
-            <a:pPr>
-              <a:spcAft>
-                <a:spcPts val="1200"/>
-              </a:spcAft>
-              <a:defRPr sz="2000">
-                <a:solidFill>
-                  <a:srgbClr val="505050"/>
-                </a:solidFill>
-                <a:latin typeface="Segoe UI"/>
-              </a:defRPr>
-            </a:pPr>
-            <a:r>
-              <a:t>• グラフィック性能強化モデルはオプション対応可能。</a:t>
+              <a:t>• 価格はすべて同一でコストパフォーマンスに優れています。</a:t>
             </a:r>
           </a:p>
         </p:txBody>
@@ -5086,7 +5022,7 @@
               </a:defRPr>
             </a:pPr>
             <a:r>
-              <a:t>• ご注文確定後、通常1週間以内に発送。</a:t>
+              <a:t>• ご注文確定後、1週間以内の納品を予定。</a:t>
             </a:r>
           </a:p>
           <a:p>
@@ -5102,7 +5038,7 @@
               </a:defRPr>
             </a:pPr>
             <a:r>
-              <a:t>• 納期調整および配送手配を速やかに実施。</a:t>
+              <a:t>• 在庫状況により納期が変動する場合があります。</a:t>
             </a:r>
           </a:p>
           <a:p>
@@ -5118,7 +5054,7 @@
               </a:defRPr>
             </a:pPr>
             <a:r>
-              <a:t>• 導入前の初期設定やソフトウェアインストールもサポート可能。</a:t>
+              <a:t>• 納品時に初期設定および動作確認を実施。</a:t>
             </a:r>
           </a:p>
           <a:p>
@@ -5134,7 +5070,7 @@
               </a:defRPr>
             </a:pPr>
             <a:r>
-              <a:t>• 全国対応のオンサイトサポートで大阪支社もカバー。</a:t>
+              <a:t>• オンサイトサポートのスケジュールは別途調整。</a:t>
             </a:r>
           </a:p>
           <a:p>
@@ -5150,23 +5086,7 @@
               </a:defRPr>
             </a:pPr>
             <a:r>
-              <a:t>• 迅速な導入で業務効率化を早期実現。</a:t>
-            </a:r>
-          </a:p>
-          <a:p>
-            <a:pPr>
-              <a:spcAft>
-                <a:spcPts val="1200"/>
-              </a:spcAft>
-              <a:defRPr sz="2000">
-                <a:solidFill>
-                  <a:srgbClr val="505050"/>
-                </a:solidFill>
-                <a:latin typeface="Segoe UI"/>
-              </a:defRPr>
-            </a:pPr>
-            <a:r>
-              <a:t>• 納期に関するご相談もお気軽にどうぞ。</a:t>
+              <a:t>• 迅速な対応でスムーズな導入をサポートします。</a:t>
             </a:r>
           </a:p>
         </p:txBody>
@@ -5302,7 +5222,7 @@
               </a:defRPr>
             </a:pPr>
             <a:r>
-              <a:t>• 本見積もり内容をご確認のうえ、ご注文の意思表示をお願いいたします。</a:t>
+              <a:t>• 本見積書をご確認のうえ、ご質問やご要望をお知らせください。</a:t>
             </a:r>
           </a:p>
           <a:p>
@@ -5318,7 +5238,7 @@
               </a:defRPr>
             </a:pPr>
             <a:r>
-              <a:t>• ご注文確定後、正式な契約書を発行いたします。</a:t>
+              <a:t>• 社内検討用の比較資料（PDF）をメール送付いたします。</a:t>
             </a:r>
           </a:p>
           <a:p>
@@ -5334,7 +5254,7 @@
               </a:defRPr>
             </a:pPr>
             <a:r>
-              <a:t>• 比較資料（PDF）を鈴木様のメールアドレスに送付予定です。</a:t>
+              <a:t>• ご承認いただけましたら正式発注の手続きをお願いいたします。</a:t>
             </a:r>
           </a:p>
           <a:p>
@@ -5350,7 +5270,7 @@
               </a:defRPr>
             </a:pPr>
             <a:r>
-              <a:t>• 追加のご質問やカスタマイズのご希望があればご連絡ください。</a:t>
+              <a:t>• 必要に応じて製品デモや技術相談のアレンジも可能です。</a:t>
             </a:r>
           </a:p>
           <a:p>
@@ -5366,23 +5286,7 @@
               </a:defRPr>
             </a:pPr>
             <a:r>
-              <a:t>• 最適なITソリューションで貴社の業務効率化を全力で支援します。</a:t>
-            </a:r>
-          </a:p>
-          <a:p>
-            <a:pPr>
-              <a:spcAft>
-                <a:spcPts val="1200"/>
-              </a:spcAft>
-              <a:defRPr sz="2000">
-                <a:solidFill>
-                  <a:srgbClr val="505050"/>
-                </a:solidFill>
-                <a:latin typeface="Segoe UI"/>
-              </a:defRPr>
-            </a:pPr>
-            <a:r>
-              <a:t>• ご連絡を心よりお待ちしております。</a:t>
+              <a:t>• 納期および導入スケジュールの最終調整を進めましょう。</a:t>
             </a:r>
           </a:p>
         </p:txBody>

</xml_diff>

<commit_message>
Removed large .bin files
</commit_message>
<xml_diff>
--- a/Data/pitch_decks/pitch_deck_001.pptx
+++ b/Data/pitch_decks/pitch_deck_001.pptx
@@ -3234,7 +3234,9 @@
                     <a:lstStyle/>
                     <a:p>
                       <a:pPr>
-                        <a:defRPr b="1" sz="1400"/>
+                        <a:defRPr b="1" sz="1400">
+                          <a:latin typeface="Segoe UI Semibold"/>
+                        </a:defRPr>
                       </a:pPr>
                       <a:r>
                         <a:t>Product Name</a:t>
@@ -3249,7 +3251,9 @@
                     <a:lstStyle/>
                     <a:p>
                       <a:pPr>
-                        <a:defRPr b="1" sz="1400"/>
+                        <a:defRPr b="1" sz="1400">
+                          <a:latin typeface="Segoe UI Semibold"/>
+                        </a:defRPr>
                       </a:pPr>
                       <a:r>
                         <a:t>Price</a:t>
@@ -3264,7 +3268,9 @@
                     <a:lstStyle/>
                     <a:p>
                       <a:pPr>
-                        <a:defRPr b="1" sz="1400"/>
+                        <a:defRPr b="1" sz="1400">
+                          <a:latin typeface="Segoe UI Semibold"/>
+                        </a:defRPr>
                       </a:pPr>
                       <a:r>
                         <a:t>CPU</a:t>
@@ -3279,7 +3285,9 @@
                     <a:lstStyle/>
                     <a:p>
                       <a:pPr>
-                        <a:defRPr b="1" sz="1400"/>
+                        <a:defRPr b="1" sz="1400">
+                          <a:latin typeface="Segoe UI Semibold"/>
+                        </a:defRPr>
                       </a:pPr>
                       <a:r>
                         <a:t>RAM</a:t>
@@ -3294,7 +3302,9 @@
                     <a:lstStyle/>
                     <a:p>
                       <a:pPr>
-                        <a:defRPr b="1" sz="1400"/>
+                        <a:defRPr b="1" sz="1400">
+                          <a:latin typeface="Segoe UI Semibold"/>
+                        </a:defRPr>
                       </a:pPr>
                       <a:r>
                         <a:t>Storage</a:t>
@@ -3309,7 +3319,9 @@
                     <a:lstStyle/>
                     <a:p>
                       <a:pPr>
-                        <a:defRPr b="1" sz="1400"/>
+                        <a:defRPr b="1" sz="1400">
+                          <a:latin typeface="Segoe UI Semibold"/>
+                        </a:defRPr>
                       </a:pPr>
                       <a:r>
                         <a:t>Warranty</a:t>
@@ -3324,7 +3336,9 @@
                     <a:lstStyle/>
                     <a:p>
                       <a:pPr>
-                        <a:defRPr b="1" sz="1400"/>
+                        <a:defRPr b="1" sz="1400">
+                          <a:latin typeface="Segoe UI Semibold"/>
+                        </a:defRPr>
                       </a:pPr>
                       <a:r>
                         <a:t>Support</a:t>
@@ -3341,7 +3355,9 @@
                     <a:lstStyle/>
                     <a:p>
                       <a:pPr>
-                        <a:defRPr sz="1200"/>
+                        <a:defRPr sz="1200">
+                          <a:latin typeface="Segoe UI"/>
+                        </a:defRPr>
                       </a:pPr>
                       <a:r>
                         <a:t>Product Name Variant 1</a:t>
@@ -3356,10 +3372,12 @@
                     <a:lstStyle/>
                     <a:p>
                       <a:pPr>
-                        <a:defRPr sz="1200"/>
+                        <a:defRPr sz="1200">
+                          <a:latin typeface="Segoe UI"/>
+                        </a:defRPr>
                       </a:pPr>
                       <a:r>
-                        <a:t>¥180,000</a:t>
+                        <a:t>4,800 JPY</a:t>
                       </a:r>
                     </a:p>
                   </a:txBody>
@@ -3371,10 +3389,12 @@
                     <a:lstStyle/>
                     <a:p>
                       <a:pPr>
-                        <a:defRPr sz="1200"/>
+                        <a:defRPr sz="1200">
+                          <a:latin typeface="Segoe UI"/>
+                        </a:defRPr>
                       </a:pPr>
                       <a:r>
-                        <a:t>Intel Core i7</a:t>
+                        <a:t>N/A</a:t>
                       </a:r>
                     </a:p>
                   </a:txBody>
@@ -3386,10 +3406,12 @@
                     <a:lstStyle/>
                     <a:p>
                       <a:pPr>
-                        <a:defRPr sz="1200"/>
+                        <a:defRPr sz="1200">
+                          <a:latin typeface="Segoe UI"/>
+                        </a:defRPr>
                       </a:pPr>
                       <a:r>
-                        <a:t>16GB</a:t>
+                        <a:t>16GB (8GBx2) DDR4 3200MHz</a:t>
                       </a:r>
                     </a:p>
                   </a:txBody>
@@ -3401,10 +3423,12 @@
                     <a:lstStyle/>
                     <a:p>
                       <a:pPr>
-                        <a:defRPr sz="1200"/>
+                        <a:defRPr sz="1200">
+                          <a:latin typeface="Segoe UI"/>
+                        </a:defRPr>
                       </a:pPr>
                       <a:r>
-                        <a:t>512GB SSD</a:t>
+                        <a:t>N/A</a:t>
                       </a:r>
                     </a:p>
                   </a:txBody>
@@ -3416,10 +3440,12 @@
                     <a:lstStyle/>
                     <a:p>
                       <a:pPr>
-                        <a:defRPr sz="1200"/>
+                        <a:defRPr sz="1200">
+                          <a:latin typeface="Segoe UI"/>
+                        </a:defRPr>
                       </a:pPr>
                       <a:r>
-                        <a:t>3年間オンサイト保証</a:t>
+                        <a:t>Standard manufacturer warranty</a:t>
                       </a:r>
                     </a:p>
                   </a:txBody>
@@ -3431,10 +3457,12 @@
                     <a:lstStyle/>
                     <a:p>
                       <a:pPr>
-                        <a:defRPr sz="1200"/>
+                        <a:defRPr sz="1200">
+                          <a:latin typeface="Segoe UI"/>
+                        </a:defRPr>
                       </a:pPr>
                       <a:r>
-                        <a:t>日本語電話・チャットサポート</a:t>
+                        <a:t>Installation support available</a:t>
                       </a:r>
                     </a:p>
                   </a:txBody>
@@ -3448,7 +3476,9 @@
                     <a:lstStyle/>
                     <a:p>
                       <a:pPr>
-                        <a:defRPr sz="1200"/>
+                        <a:defRPr sz="1200">
+                          <a:latin typeface="Segoe UI"/>
+                        </a:defRPr>
                       </a:pPr>
                       <a:r>
                         <a:t>Product Name Variant 2</a:t>
@@ -3463,10 +3493,12 @@
                     <a:lstStyle/>
                     <a:p>
                       <a:pPr>
-                        <a:defRPr sz="1200"/>
+                        <a:defRPr sz="1200">
+                          <a:latin typeface="Segoe UI"/>
+                        </a:defRPr>
                       </a:pPr>
                       <a:r>
-                        <a:t>¥180,000</a:t>
+                        <a:t>5,200 JPY</a:t>
                       </a:r>
                     </a:p>
                   </a:txBody>
@@ -3478,10 +3510,12 @@
                     <a:lstStyle/>
                     <a:p>
                       <a:pPr>
-                        <a:defRPr sz="1200"/>
+                        <a:defRPr sz="1200">
+                          <a:latin typeface="Segoe UI"/>
+                        </a:defRPr>
                       </a:pPr>
                       <a:r>
-                        <a:t>Intel Core i7</a:t>
+                        <a:t>N/A</a:t>
                       </a:r>
                     </a:p>
                   </a:txBody>
@@ -3493,10 +3527,12 @@
                     <a:lstStyle/>
                     <a:p>
                       <a:pPr>
-                        <a:defRPr sz="1200"/>
+                        <a:defRPr sz="1200">
+                          <a:latin typeface="Segoe UI"/>
+                        </a:defRPr>
                       </a:pPr>
                       <a:r>
-                        <a:t>16GB</a:t>
+                        <a:t>16GB (8GBx2) DDR4 2666MHz</a:t>
                       </a:r>
                     </a:p>
                   </a:txBody>
@@ -3508,10 +3544,12 @@
                     <a:lstStyle/>
                     <a:p>
                       <a:pPr>
-                        <a:defRPr sz="1200"/>
+                        <a:defRPr sz="1200">
+                          <a:latin typeface="Segoe UI"/>
+                        </a:defRPr>
                       </a:pPr>
                       <a:r>
-                        <a:t>512GB SSD</a:t>
+                        <a:t>N/A</a:t>
                       </a:r>
                     </a:p>
                   </a:txBody>
@@ -3523,10 +3561,12 @@
                     <a:lstStyle/>
                     <a:p>
                       <a:pPr>
-                        <a:defRPr sz="1200"/>
+                        <a:defRPr sz="1200">
+                          <a:latin typeface="Segoe UI"/>
+                        </a:defRPr>
                       </a:pPr>
                       <a:r>
-                        <a:t>3年間オンサイト保証</a:t>
+                        <a:t>Standard manufacturer warranty</a:t>
                       </a:r>
                     </a:p>
                   </a:txBody>
@@ -3538,10 +3578,12 @@
                     <a:lstStyle/>
                     <a:p>
                       <a:pPr>
-                        <a:defRPr sz="1200"/>
+                        <a:defRPr sz="1200">
+                          <a:latin typeface="Segoe UI"/>
+                        </a:defRPr>
                       </a:pPr>
                       <a:r>
-                        <a:t>日本語電話・チャットサポート</a:t>
+                        <a:t>Installation support available</a:t>
                       </a:r>
                     </a:p>
                   </a:txBody>
@@ -3555,7 +3597,9 @@
                     <a:lstStyle/>
                     <a:p>
                       <a:pPr>
-                        <a:defRPr sz="1200"/>
+                        <a:defRPr sz="1200">
+                          <a:latin typeface="Segoe UI"/>
+                        </a:defRPr>
                       </a:pPr>
                       <a:r>
                         <a:t>Product Name Variant 3</a:t>
@@ -3570,10 +3614,12 @@
                     <a:lstStyle/>
                     <a:p>
                       <a:pPr>
-                        <a:defRPr sz="1200"/>
+                        <a:defRPr sz="1200">
+                          <a:latin typeface="Segoe UI"/>
+                        </a:defRPr>
                       </a:pPr>
                       <a:r>
-                        <a:t>¥180,000</a:t>
+                        <a:t>4,800 JPY</a:t>
                       </a:r>
                     </a:p>
                   </a:txBody>
@@ -3585,10 +3631,12 @@
                     <a:lstStyle/>
                     <a:p>
                       <a:pPr>
-                        <a:defRPr sz="1200"/>
+                        <a:defRPr sz="1200">
+                          <a:latin typeface="Segoe UI"/>
+                        </a:defRPr>
                       </a:pPr>
                       <a:r>
-                        <a:t>Intel Core i7</a:t>
+                        <a:t>N/A</a:t>
                       </a:r>
                     </a:p>
                   </a:txBody>
@@ -3600,10 +3648,12 @@
                     <a:lstStyle/>
                     <a:p>
                       <a:pPr>
-                        <a:defRPr sz="1200"/>
+                        <a:defRPr sz="1200">
+                          <a:latin typeface="Segoe UI"/>
+                        </a:defRPr>
                       </a:pPr>
                       <a:r>
-                        <a:t>16GB</a:t>
+                        <a:t>16GB (8GBx2) DDR4 3200MHz</a:t>
                       </a:r>
                     </a:p>
                   </a:txBody>
@@ -3615,10 +3665,12 @@
                     <a:lstStyle/>
                     <a:p>
                       <a:pPr>
-                        <a:defRPr sz="1200"/>
+                        <a:defRPr sz="1200">
+                          <a:latin typeface="Segoe UI"/>
+                        </a:defRPr>
                       </a:pPr>
                       <a:r>
-                        <a:t>512GB SSD</a:t>
+                        <a:t>N/A</a:t>
                       </a:r>
                     </a:p>
                   </a:txBody>
@@ -3630,10 +3682,12 @@
                     <a:lstStyle/>
                     <a:p>
                       <a:pPr>
-                        <a:defRPr sz="1200"/>
+                        <a:defRPr sz="1200">
+                          <a:latin typeface="Segoe UI"/>
+                        </a:defRPr>
                       </a:pPr>
                       <a:r>
-                        <a:t>3年間オンサイト保証</a:t>
+                        <a:t>Standard manufacturer warranty</a:t>
                       </a:r>
                     </a:p>
                   </a:txBody>
@@ -3645,10 +3699,12 @@
                     <a:lstStyle/>
                     <a:p>
                       <a:pPr>
-                        <a:defRPr sz="1200"/>
+                        <a:defRPr sz="1200">
+                          <a:latin typeface="Segoe UI"/>
+                        </a:defRPr>
                       </a:pPr>
                       <a:r>
-                        <a:t>日本語電話・チャットサポート</a:t>
+                        <a:t>Installation support available</a:t>
                       </a:r>
                     </a:p>
                   </a:txBody>
@@ -3790,7 +3846,7 @@
               </a:defRPr>
             </a:pPr>
             <a:r>
-              <a:t>• 株式会社クロステック様はコンサルティング業務での効率化を目指しています。</a:t>
+              <a:t>• Seeking reliable and cost-effective DDR4 laptop memory modules.</a:t>
             </a:r>
           </a:p>
           <a:p>
@@ -3806,7 +3862,7 @@
               </a:defRPr>
             </a:pPr>
             <a:r>
-              <a:t>• 資料作成、Zoom会議、プレゼンテーション、軽いグラフィック編集が主な作業。</a:t>
+              <a:t>• Requires 16GB total capacity (8GBx2) for programming and light video editing.</a:t>
             </a:r>
           </a:p>
           <a:p>
@@ -3822,7 +3878,7 @@
               </a:defRPr>
             </a:pPr>
             <a:r>
-              <a:t>• 軽量かつ高解像度ディスプレイ搭載のノートパソコンを5台導入希望。</a:t>
+              <a:t>• Prioritizes stability and performance for smooth multitasking.</a:t>
             </a:r>
           </a:p>
           <a:p>
@@ -3838,7 +3894,7 @@
               </a:defRPr>
             </a:pPr>
             <a:r>
-              <a:t>• 長時間バッテリー駆動と静音設計を重視。</a:t>
+              <a:t>• Budget range between 7,000 and 10,000 JPY.</a:t>
             </a:r>
           </a:p>
           <a:p>
@@ -3854,7 +3910,23 @@
               </a:defRPr>
             </a:pPr>
             <a:r>
-              <a:t>• 迅速な故障対応と3年間のハードウェア保証、全国対応のオンサイトサポートを求めています。</a:t>
+              <a:t>• Prefers trusted brands with good cost performance.</a:t>
+            </a:r>
+          </a:p>
+          <a:p>
+            <a:pPr>
+              <a:spcAft>
+                <a:spcPts val="1200"/>
+              </a:spcAft>
+              <a:defRPr sz="2000">
+                <a:solidFill>
+                  <a:srgbClr val="505050"/>
+                </a:solidFill>
+                <a:latin typeface="Segoe UI"/>
+              </a:defRPr>
+            </a:pPr>
+            <a:r>
+              <a:t>• Requests a quick quote within 1-2 days.</a:t>
             </a:r>
           </a:p>
         </p:txBody>
@@ -3990,7 +4062,7 @@
               </a:defRPr>
             </a:pPr>
             <a:r>
-              <a:t>• 高性能15.6インチノートPCモデルCを5台ご提案。</a:t>
+              <a:t>• Offering high-quality DDR4 16GB (8GBx2) laptop memory kits.</a:t>
             </a:r>
           </a:p>
           <a:p>
@@ -4006,7 +4078,7 @@
               </a:defRPr>
             </a:pPr>
             <a:r>
-              <a:t>• 法人向け3年オンサイト対応保証と日本語電話サポート付き。</a:t>
+              <a:t>• Products selected for optimal balance of speed, stability, and cost efficiency.</a:t>
             </a:r>
           </a:p>
           <a:p>
@@ -4022,7 +4094,7 @@
               </a:defRPr>
             </a:pPr>
             <a:r>
-              <a:t>• 延長保証プランで翌営業日オンサイト対応を実現。</a:t>
+              <a:t>• Trusted brands like Crucial and Kingston included to meet reliability needs.</a:t>
             </a:r>
           </a:p>
           <a:p>
@@ -4038,7 +4110,7 @@
               </a:defRPr>
             </a:pPr>
             <a:r>
-              <a:t>• 日本語電話・チャットサポートプランで迅速な問題解決を支援。</a:t>
+              <a:t>• Competitive pricing within the customer's budget range.</a:t>
             </a:r>
           </a:p>
           <a:p>
@@ -4054,7 +4126,23 @@
               </a:defRPr>
             </a:pPr>
             <a:r>
-              <a:t>• 軽量・長時間駆動・静音設計で業務効率を最大化。</a:t>
+              <a:t>• Fast quotation and delivery process to meet customer timeline.</a:t>
+            </a:r>
+          </a:p>
+          <a:p>
+            <a:pPr>
+              <a:spcAft>
+                <a:spcPts val="1200"/>
+              </a:spcAft>
+              <a:defRPr sz="2000">
+                <a:solidFill>
+                  <a:srgbClr val="505050"/>
+                </a:solidFill>
+                <a:latin typeface="Segoe UI"/>
+              </a:defRPr>
+            </a:pPr>
+            <a:r>
+              <a:t>• Support available for installation and compatibility confirmation.</a:t>
             </a:r>
           </a:p>
         </p:txBody>
@@ -4190,7 +4278,7 @@
               </a:defRPr>
             </a:pPr>
             <a:r>
-              <a:t>• CPU: Intel Core i7搭載で高い処理性能を実現。</a:t>
+              <a:t>• Crucial 16GB Kit: DDR4, 3200MHz, 8GBx2 modules.</a:t>
             </a:r>
           </a:p>
           <a:p>
@@ -4206,7 +4294,7 @@
               </a:defRPr>
             </a:pPr>
             <a:r>
-              <a:t>• メモリ: 16GB RAMでマルチタスクもスムーズ。</a:t>
+              <a:t>• Kingston 16GB Kit: DDR4, 2666MHz, 8GBx2 modules.</a:t>
             </a:r>
           </a:p>
           <a:p>
@@ -4222,7 +4310,7 @@
               </a:defRPr>
             </a:pPr>
             <a:r>
-              <a:t>• ストレージ: 512GB SSDで高速アクセスと大容量を両立。</a:t>
+              <a:t>• Both kits designed for programming and multimedia tasks.</a:t>
             </a:r>
           </a:p>
           <a:p>
@@ -4238,7 +4326,7 @@
               </a:defRPr>
             </a:pPr>
             <a:r>
-              <a:t>• ディスプレイ: 15.6インチフルHD高解像度で見やすい画面。</a:t>
+              <a:t>• Stable performance optimized for laptops.</a:t>
             </a:r>
           </a:p>
           <a:p>
@@ -4254,7 +4342,7 @@
               </a:defRPr>
             </a:pPr>
             <a:r>
-              <a:t>• 重量: 約1.6kgの軽量設計で持ち運びも快適。</a:t>
+              <a:t>• Standard manufacturer warranty applies.</a:t>
             </a:r>
           </a:p>
           <a:p>
@@ -4270,7 +4358,7 @@
               </a:defRPr>
             </a:pPr>
             <a:r>
-              <a:t>• バッテリー: 最大15時間駆動、静音設計で快適な作業環境を提供。</a:t>
+              <a:t>• Compatible with most modern laptop models (confirm compatibility).</a:t>
             </a:r>
           </a:p>
         </p:txBody>
@@ -4406,7 +4494,7 @@
               </a:defRPr>
             </a:pPr>
             <a:r>
-              <a:t>• モデルCノートPC（5台）合計: ¥900,000</a:t>
+              <a:t>• Crucial 16GB Kit priced at 4,800 JPY.</a:t>
             </a:r>
           </a:p>
           <a:p>
@@ -4422,7 +4510,7 @@
               </a:defRPr>
             </a:pPr>
             <a:r>
-              <a:t>• 延長保証プラン（5台分）: ¥40,000</a:t>
+              <a:t>• Kingston 16GB Kit priced at 5,200 JPY.</a:t>
             </a:r>
           </a:p>
           <a:p>
@@ -4438,7 +4526,7 @@
               </a:defRPr>
             </a:pPr>
             <a:r>
-              <a:t>• 法人向け電話・チャットサポートプラン（3年間）: ¥35,000</a:t>
+              <a:t>• Subtotal for selected products: 10,000 JPY.</a:t>
             </a:r>
           </a:p>
           <a:p>
@@ -4454,7 +4542,7 @@
               </a:defRPr>
             </a:pPr>
             <a:r>
-              <a:t>• 小計: ¥975,000</a:t>
+              <a:t>• Tax (8%) adds 800 JPY, total amounting to 10,800 JPY.</a:t>
             </a:r>
           </a:p>
           <a:p>
@@ -4470,7 +4558,7 @@
               </a:defRPr>
             </a:pPr>
             <a:r>
-              <a:t>• 消費税10%: ¥97,500</a:t>
+              <a:t>• Competitive pricing ensures excellent value within budget.</a:t>
             </a:r>
           </a:p>
           <a:p>
@@ -4486,7 +4574,7 @@
               </a:defRPr>
             </a:pPr>
             <a:r>
-              <a:t>• 合計金額: ¥1,072,500</a:t>
+              <a:t>• Prices valid for 30 days from quote date.</a:t>
             </a:r>
           </a:p>
         </p:txBody>
@@ -4622,7 +4710,7 @@
               </a:defRPr>
             </a:pPr>
             <a:r>
-              <a:t>• 3年間の法人向けオンサイト保証付き。</a:t>
+              <a:t>• Standard manufacturer warranty included with all products.</a:t>
             </a:r>
           </a:p>
           <a:p>
@@ -4638,7 +4726,7 @@
               </a:defRPr>
             </a:pPr>
             <a:r>
-              <a:t>• 故障時は翌営業日に全国対応でオンサイトサポート。</a:t>
+              <a:t>• Returns accepted within 14 days if unopened and in original packaging.</a:t>
             </a:r>
           </a:p>
           <a:p>
@@ -4654,7 +4742,7 @@
               </a:defRPr>
             </a:pPr>
             <a:r>
-              <a:t>• 日本語対応の電話・チャットサポートで迅速なトラブル解決。</a:t>
+              <a:t>• Payment terms: 30 days net from invoice date.</a:t>
             </a:r>
           </a:p>
           <a:p>
@@ -4670,7 +4758,7 @@
               </a:defRPr>
             </a:pPr>
             <a:r>
-              <a:t>• 延長保証プランで安心の長期サポートを提供。</a:t>
+              <a:t>• Delivery estimated within 5 business days after order confirmation.</a:t>
             </a:r>
           </a:p>
           <a:p>
@@ -4686,7 +4774,23 @@
               </a:defRPr>
             </a:pPr>
             <a:r>
-              <a:t>• 大阪支社も含む全国対応体制で安心のサービスネットワーク。</a:t>
+              <a:t>• Installation can be done by customer or professional technician.</a:t>
+            </a:r>
+          </a:p>
+          <a:p>
+            <a:pPr>
+              <a:spcAft>
+                <a:spcPts val="1200"/>
+              </a:spcAft>
+              <a:defRPr sz="2000">
+                <a:solidFill>
+                  <a:srgbClr val="505050"/>
+                </a:solidFill>
+                <a:latin typeface="Segoe UI"/>
+              </a:defRPr>
+            </a:pPr>
+            <a:r>
+              <a:t>• BIOS update recommended to ensure optimal performance.</a:t>
             </a:r>
           </a:p>
         </p:txBody>
@@ -4822,7 +4926,7 @@
               </a:defRPr>
             </a:pPr>
             <a:r>
-              <a:t>• 3つのバリエーションで性能は同等、名称のみ異なります。</a:t>
+              <a:t>• Compare three variants of DDR4 16GB (8GBx2) laptop memory kits.</a:t>
             </a:r>
           </a:p>
           <a:p>
@@ -4838,7 +4942,7 @@
               </a:defRPr>
             </a:pPr>
             <a:r>
-              <a:t>• すべて15.6インチフルHDディスプレイ搭載。</a:t>
+              <a:t>• All offer stable performance and cost-effective solutions.</a:t>
             </a:r>
           </a:p>
           <a:p>
@@ -4854,7 +4958,7 @@
               </a:defRPr>
             </a:pPr>
             <a:r>
-              <a:t>• Intel Core i7、16GB RAM、512GB SSDの高性能構成。</a:t>
+              <a:t>• Differences in speed and brand reliability to suit preferences.</a:t>
             </a:r>
           </a:p>
           <a:p>
@@ -4870,7 +4974,7 @@
               </a:defRPr>
             </a:pPr>
             <a:r>
-              <a:t>• 3年間のオンサイト保証と日本語サポート付き。</a:t>
+              <a:t>• Each variant priced competitively within budget range.</a:t>
             </a:r>
           </a:p>
           <a:p>
@@ -4886,7 +4990,23 @@
               </a:defRPr>
             </a:pPr>
             <a:r>
-              <a:t>• 価格はすべて同一でコストパフォーマンスに優れています。</a:t>
+              <a:t>• Helps select the best fit for programming and multimedia needs.</a:t>
+            </a:r>
+          </a:p>
+          <a:p>
+            <a:pPr>
+              <a:spcAft>
+                <a:spcPts val="1200"/>
+              </a:spcAft>
+              <a:defRPr sz="2000">
+                <a:solidFill>
+                  <a:srgbClr val="505050"/>
+                </a:solidFill>
+                <a:latin typeface="Segoe UI"/>
+              </a:defRPr>
+            </a:pPr>
+            <a:r>
+              <a:t>• Detailed specs and pricing available for informed decision.</a:t>
             </a:r>
           </a:p>
         </p:txBody>
@@ -5022,7 +5142,7 @@
               </a:defRPr>
             </a:pPr>
             <a:r>
-              <a:t>• ご注文確定後、1週間以内の納品を予定。</a:t>
+              <a:t>• Order confirmation triggers delivery process.</a:t>
             </a:r>
           </a:p>
           <a:p>
@@ -5038,7 +5158,7 @@
               </a:defRPr>
             </a:pPr>
             <a:r>
-              <a:t>• 在庫状況により納期が変動する場合があります。</a:t>
+              <a:t>• Estimated delivery within 5 business days.</a:t>
             </a:r>
           </a:p>
           <a:p>
@@ -5054,7 +5174,7 @@
               </a:defRPr>
             </a:pPr>
             <a:r>
-              <a:t>• 納品時に初期設定および動作確認を実施。</a:t>
+              <a:t>• Quick processing to meet customer's urgent requirements.</a:t>
             </a:r>
           </a:p>
           <a:p>
@@ -5070,7 +5190,7 @@
               </a:defRPr>
             </a:pPr>
             <a:r>
-              <a:t>• オンサイトサポートのスケジュールは別途調整。</a:t>
+              <a:t>• Shipping details confirmed upon order placement.</a:t>
             </a:r>
           </a:p>
           <a:p>
@@ -5086,7 +5206,23 @@
               </a:defRPr>
             </a:pPr>
             <a:r>
-              <a:t>• 迅速な対応でスムーズな導入をサポートします。</a:t>
+              <a:t>• Installation support available upon request.</a:t>
+            </a:r>
+          </a:p>
+          <a:p>
+            <a:pPr>
+              <a:spcAft>
+                <a:spcPts val="1200"/>
+              </a:spcAft>
+              <a:defRPr sz="2000">
+                <a:solidFill>
+                  <a:srgbClr val="505050"/>
+                </a:solidFill>
+                <a:latin typeface="Segoe UI"/>
+              </a:defRPr>
+            </a:pPr>
+            <a:r>
+              <a:t>• Ensures minimal downtime and fast upgrade.</a:t>
             </a:r>
           </a:p>
         </p:txBody>
@@ -5222,7 +5358,7 @@
               </a:defRPr>
             </a:pPr>
             <a:r>
-              <a:t>• 本見積書をご確認のうえ、ご質問やご要望をお知らせください。</a:t>
+              <a:t>• Review the proposed memory options and select your preferred product.</a:t>
             </a:r>
           </a:p>
           <a:p>
@@ -5238,7 +5374,7 @@
               </a:defRPr>
             </a:pPr>
             <a:r>
-              <a:t>• 社内検討用の比較資料（PDF）をメール送付いたします。</a:t>
+              <a:t>• Confirm order details and provide shipping information.</a:t>
             </a:r>
           </a:p>
           <a:p>
@@ -5254,7 +5390,7 @@
               </a:defRPr>
             </a:pPr>
             <a:r>
-              <a:t>• ご承認いただけましたら正式発注の手続きをお願いいたします。</a:t>
+              <a:t>• Process payment to initiate order fulfillment.</a:t>
             </a:r>
           </a:p>
           <a:p>
@@ -5270,7 +5406,7 @@
               </a:defRPr>
             </a:pPr>
             <a:r>
-              <a:t>• 必要に応じて製品デモや技術相談のアレンジも可能です。</a:t>
+              <a:t>• Schedule delivery and installation as needed.</a:t>
             </a:r>
           </a:p>
           <a:p>
@@ -5286,7 +5422,23 @@
               </a:defRPr>
             </a:pPr>
             <a:r>
-              <a:t>• 納期および導入スケジュールの最終調整を進めましょう。</a:t>
+              <a:t>• Contact us for any questions or compatibility checks.</a:t>
+            </a:r>
+          </a:p>
+          <a:p>
+            <a:pPr>
+              <a:spcAft>
+                <a:spcPts val="1200"/>
+              </a:spcAft>
+              <a:defRPr sz="2000">
+                <a:solidFill>
+                  <a:srgbClr val="505050"/>
+                </a:solidFill>
+                <a:latin typeface="Segoe UI"/>
+              </a:defRPr>
+            </a:pPr>
+            <a:r>
+              <a:t>• Upgrade your laptop performance with reliable memory today!</a:t>
             </a:r>
           </a:p>
         </p:txBody>

</xml_diff>